<commit_message>
Evidence: complete and audit 12-task laptop evaluation
Preserve all 48 raw responses, record separate manual assessments, and publish per-task correctness, latency, loading and memory. Update the intended presentation while retaining the pilot and clean-checkout limitations.
</commit_message>
<xml_diff>
--- a/docs/presentation/LeanMoE-Submission-Final.pptx
+++ b/docs/presentation/LeanMoE-Submission-Final.pptx
@@ -5263,28 +5263,27 @@
               <a:buNone/>
             </a:pPr>
             <a:r>
-              <a:rPr lang="en-US" sz="1700" b="1" dirty="0">
+              <a:rPr lang="en-US" sz="1700" b="1">
                 <a:solidFill>
                   <a:srgbClr val="0E2A23"/>
                 </a:solidFill>
-                <a:latin typeface="Geist Bold" pitchFamily="34" charset="0"/>
+                <a:latin typeface="Geist Bold" panose="020B0604020202020204" charset="0"/>
                 <a:ea typeface="Geist Bold" pitchFamily="34" charset="-122"/>
                 <a:cs typeface="Geist Bold" pitchFamily="34" charset="0"/>
               </a:rPr>
               <a:t>Evaluate:</a:t>
             </a:r>
             <a:r>
-              <a:rPr lang="en-US" sz="1700" dirty="0">
+              <a:rPr lang="en-US" sz="1700">
                 <a:solidFill>
                   <a:srgbClr val="0E2A23"/>
                 </a:solidFill>
-                <a:latin typeface="Geist" pitchFamily="34" charset="0"/>
-                <a:ea typeface="Geist" pitchFamily="34" charset="-122"/>
-                <a:cs typeface="Geist" pitchFamily="34" charset="0"/>
-              </a:rPr>
-              <a:t> Complete task-success evaluation with latency requirements; test more models and constrained devices.</a:t>
-            </a:r>
-            <a:endParaRPr lang="en-US" sz="1700" dirty="0"/>
+                <a:latin typeface="Geist" panose="020B0604020202020204" charset="0"/>
+                <a:ea typeface="Geist Bold" pitchFamily="34" charset="-122"/>
+                <a:cs typeface="Geist Bold" pitchFamily="34" charset="0"/>
+              </a:rPr>
+              <a:t> Test more models and constrained devices.</a:t>
+            </a:r>
           </a:p>
           <a:p>
             <a:pPr marL="0" indent="0" algn="l">
@@ -5297,59 +5296,66 @@
               <a:buNone/>
             </a:pPr>
             <a:r>
-              <a:rPr lang="en-US" sz="1700" b="1" dirty="0">
+              <a:rPr lang="en-US" sz="1700" b="1">
                 <a:solidFill>
                   <a:srgbClr val="0E2A23"/>
                 </a:solidFill>
-                <a:latin typeface="Geist Bold" pitchFamily="34" charset="0"/>
+                <a:latin typeface="Geist Bold" panose="020B0604020202020204" charset="0"/>
                 <a:ea typeface="Geist Bold" pitchFamily="34" charset="-122"/>
                 <a:cs typeface="Geist Bold" pitchFamily="34" charset="0"/>
               </a:rPr>
               <a:t>Build:</a:t>
             </a:r>
             <a:r>
-              <a:rPr lang="en-US" sz="1700" dirty="0">
+              <a:rPr lang="en-US" sz="1700">
                 <a:solidFill>
                   <a:srgbClr val="0E2A23"/>
                 </a:solidFill>
-                <a:latin typeface="Geist" pitchFamily="34" charset="0"/>
-                <a:ea typeface="Geist" pitchFamily="34" charset="-122"/>
-                <a:cs typeface="Geist" pitchFamily="34" charset="0"/>
-              </a:rPr>
-              <a:t> Simplify model-store setup and improve memory feedback from measured usage.</a:t>
-            </a:r>
-            <a:endParaRPr lang="en-US" sz="1700" dirty="0"/>
-          </a:p>
-          <a:p>
-            <a:pPr marL="0" indent="0" algn="l">
-              <a:lnSpc>
-                <a:spcPct val="117000"/>
-              </a:lnSpc>
-              <a:buNone/>
-            </a:pPr>
-            <a:r>
-              <a:rPr lang="en-US" sz="1700" b="1" dirty="0">
-                <a:solidFill>
-                  <a:srgbClr val="0E2A23"/>
-                </a:solidFill>
-                <a:latin typeface="Geist Bold" pitchFamily="34" charset="0"/>
+                <a:latin typeface="Geist" panose="020B0604020202020204" charset="0"/>
                 <a:ea typeface="Geist Bold" pitchFamily="34" charset="-122"/>
                 <a:cs typeface="Geist Bold" pitchFamily="34" charset="0"/>
               </a:rPr>
+              <a:t> Simplify model-store setup and improve memory feedback from measured usage.</a:t>
+            </a:r>
+          </a:p>
+          <a:p>
+            <a:pPr marL="0" indent="0" algn="l">
+              <a:lnSpc>
+                <a:spcPct val="117000"/>
+              </a:lnSpc>
+              <a:spcAft>
+                <a:spcPts val="1250"/>
+              </a:spcAft>
+              <a:buNone/>
+            </a:pPr>
+            <a:r>
+              <a:rPr lang="en-US" sz="1700" b="1">
+                <a:solidFill>
+                  <a:srgbClr val="0E2A23"/>
+                </a:solidFill>
+                <a:latin typeface="Geist Bold" panose="020B0604020202020204" charset="0"/>
+                <a:ea typeface="Geist Bold" pitchFamily="34" charset="-122"/>
+                <a:cs typeface="Geist Bold" pitchFamily="34" charset="0"/>
+              </a:rPr>
               <a:t>Evidence boundary:</a:t>
             </a:r>
             <a:r>
-              <a:rPr lang="en-US" sz="1700" dirty="0">
+              <a:rPr lang="en-US" sz="1700">
                 <a:solidFill>
                   <a:srgbClr val="0E2A23"/>
                 </a:solidFill>
-                <a:latin typeface="Geist" pitchFamily="34" charset="0"/>
-                <a:ea typeface="Geist" pitchFamily="34" charset="-122"/>
-                <a:cs typeface="Geist" pitchFamily="34" charset="0"/>
-              </a:rPr>
-              <a:t> The full 12-task evaluation was unfinished at the latest confirmed checkpoint; the earlier three-task pilot was only a harness check.</a:t>
-            </a:r>
-            <a:endParaRPr lang="en-US" sz="1700" dirty="0"/>
+                <a:latin typeface="Geist" panose="020B0604020202020204" charset="0"/>
+                <a:ea typeface="Geist Bold" pitchFamily="34" charset="-122"/>
+                <a:cs typeface="Geist Bold" pitchFamily="34" charset="0"/>
+              </a:rPr>
+              <a:t> Full 12-task laptop check: 8/12 correct and within 120 seconds per mode, first and warm. Four tasks wrong; the earlier three-task pilot was a harness check.</a:t>
+            </a:r>
+            <a:endParaRPr lang="en-US" sz="1700" dirty="0">
+              <a:solidFill>
+                <a:srgbClr val="0E2A23"/>
+              </a:solidFill>
+              <a:latin typeface="Geist" panose="020B0604020202020204" charset="0"/>
+            </a:endParaRPr>
           </a:p>
         </p:txBody>
       </p:sp>

</xml_diff>